<commit_message>
docs: keep submission files out of the public repo
The report and slides are submitted through the portal and carry the
team's student IDs and emails, so they are no longer tracked.
</commit_message>
<xml_diff>
--- a/docs/presentation/SalaryBridge.pptx
+++ b/docs/presentation/SalaryBridge.pptx
@@ -2227,7 +2227,7 @@
           </a:prstGeom>
           <a:extLst>
             <a:ext uri="{C572A759-6A51-4108-AA02-DFA0A04FC94B}">
-              <ma14:wrappingTextBoxFlag xmlns:ma14="http://schemas.microsoft.com/office/mac/drawingml/2011/main" xmlns="" val="0"/>
+              <ma14:wrappingTextBoxFlag xmlns="" xmlns:ma14="http://schemas.microsoft.com/office/mac/drawingml/2011/main" val="0"/>
             </a:ext>
           </a:extLst>
         </p:spPr>
@@ -2385,7 +2385,7 @@
           </a:prstGeom>
           <a:extLst>
             <a:ext uri="{C572A759-6A51-4108-AA02-DFA0A04FC94B}">
-              <ma14:wrappingTextBoxFlag xmlns:ma14="http://schemas.microsoft.com/office/mac/drawingml/2011/main" xmlns="" val="0"/>
+              <ma14:wrappingTextBoxFlag xmlns="" xmlns:ma14="http://schemas.microsoft.com/office/mac/drawingml/2011/main" val="0"/>
             </a:ext>
           </a:extLst>
         </p:spPr>
@@ -2460,7 +2460,7 @@
           </a:prstGeom>
           <a:extLst>
             <a:ext uri="{C572A759-6A51-4108-AA02-DFA0A04FC94B}">
-              <ma14:wrappingTextBoxFlag xmlns:ma14="http://schemas.microsoft.com/office/mac/drawingml/2011/main" xmlns="" val="0"/>
+              <ma14:wrappingTextBoxFlag xmlns="" xmlns:ma14="http://schemas.microsoft.com/office/mac/drawingml/2011/main" val="0"/>
             </a:ext>
           </a:extLst>
         </p:spPr>
@@ -3060,7 +3060,7 @@
                   <a:schemeClr val="accent5"/>
                 </a:solidFill>
               </a:rPr>
-              <a:t>Daffodil International University ·  </a:t>
+              <a:t>Daffodil International University </a:t>
             </a:r>
             <a:br>
               <a:rPr lang="en-US" sz="1400" dirty="0">
@@ -3083,7 +3083,15 @@
                   <a:schemeClr val="accent5"/>
                 </a:solidFill>
               </a:rPr>
-              <a:t>rack 03 · Customer Innovation &amp; Financial Independence.</a:t>
+              <a:t>rack 03 · Customer Innovation &amp; </a:t>
+            </a:r>
+            <a:r>
+              <a:rPr lang="en-GB" sz="1400">
+                <a:solidFill>
+                  <a:schemeClr val="accent5"/>
+                </a:solidFill>
+              </a:rPr>
+              <a:t>Financial Independence</a:t>
             </a:r>
             <a:endParaRPr lang="en-US" sz="1400" dirty="0"/>
           </a:p>
@@ -3936,7 +3944,7 @@
                   <a:schemeClr val="accent5"/>
                 </a:solidFill>
               </a:rPr>
-              <a:t>Leader , Frontend, Ai Engineer ·  </a:t>
+              <a:t>Leader, Frontend, AI Engineer </a:t>
             </a:r>
           </a:p>
           <a:p>
@@ -3949,7 +3957,7 @@
                   <a:schemeClr val="accent5"/>
                 </a:solidFill>
               </a:rPr>
-              <a:t>CSE Department, Daffodil International University  ·  quym241-15-053@diu.edu.bd</a:t>
+              <a:t>CSE Department, Daffodil International University  quym241-15-053@diu.edu.bd</a:t>
             </a:r>
             <a:endParaRPr lang="en-US" sz="1300" dirty="0"/>
           </a:p>
@@ -4101,7 +4109,7 @@
                   <a:schemeClr val="accent5"/>
                 </a:solidFill>
               </a:rPr>
-              <a:t>Ai/ML ·  </a:t>
+              <a:t>AI/ML  </a:t>
             </a:r>
           </a:p>
           <a:p>
@@ -4111,7 +4119,7 @@
                   <a:schemeClr val="accent5"/>
                 </a:solidFill>
               </a:rPr>
-              <a:t>CSE Department, Daffodil International University  ·  sajid241-15-909@diu.edu.bd</a:t>
+              <a:t>CSE Department, Daffodil International University   sajid241-15-909@diu.edu.bd</a:t>
             </a:r>
             <a:endParaRPr lang="en-US" sz="1300" dirty="0"/>
           </a:p>
@@ -4260,7 +4268,7 @@
                   <a:schemeClr val="accent5"/>
                 </a:solidFill>
               </a:rPr>
-              <a:t>Backend Engineer  ·  </a:t>
+              <a:t>Backend Engineer   </a:t>
             </a:r>
           </a:p>
           <a:p>
@@ -4270,7 +4278,23 @@
                   <a:schemeClr val="accent5"/>
                 </a:solidFill>
               </a:rPr>
-              <a:t>CSE Department, Daffodil International University  ·  sakib241-15-048@diu.edu.bd</a:t>
+              <a:t>CSE Department, Daffodil International </a:t>
+            </a:r>
+            <a:r>
+              <a:rPr lang="en-US" sz="1300">
+                <a:solidFill>
+                  <a:schemeClr val="accent5"/>
+                </a:solidFill>
+              </a:rPr>
+              <a:t>University   </a:t>
+            </a:r>
+            <a:r>
+              <a:rPr lang="en-US" sz="1300" dirty="0">
+                <a:solidFill>
+                  <a:schemeClr val="accent5"/>
+                </a:solidFill>
+              </a:rPr>
+              <a:t>sakib241-15-048@diu.edu.bd</a:t>
             </a:r>
             <a:endParaRPr lang="en-US" sz="1300" dirty="0"/>
           </a:p>
@@ -4296,7 +4320,7 @@
           </a:prstGeom>
           <a:extLst>
             <a:ext uri="{C572A759-6A51-4108-AA02-DFA0A04FC94B}">
-              <ma14:wrappingTextBoxFlag xmlns:ma14="http://schemas.microsoft.com/office/mac/drawingml/2011/main" xmlns="" val="0"/>
+              <ma14:wrappingTextBoxFlag xmlns="" xmlns:ma14="http://schemas.microsoft.com/office/mac/drawingml/2011/main" val="0"/>
             </a:ext>
           </a:extLst>
         </p:spPr>
@@ -5122,7 +5146,7 @@
           </a:prstGeom>
           <a:extLst>
             <a:ext uri="{C572A759-6A51-4108-AA02-DFA0A04FC94B}">
-              <ma14:wrappingTextBoxFlag xmlns:ma14="http://schemas.microsoft.com/office/mac/drawingml/2011/main" xmlns="" val="0"/>
+              <ma14:wrappingTextBoxFlag xmlns="" xmlns:ma14="http://schemas.microsoft.com/office/mac/drawingml/2011/main" val="0"/>
             </a:ext>
           </a:extLst>
         </p:spPr>
@@ -6446,7 +6470,7 @@
           </a:prstGeom>
           <a:extLst>
             <a:ext uri="{C572A759-6A51-4108-AA02-DFA0A04FC94B}">
-              <ma14:wrappingTextBoxFlag xmlns:ma14="http://schemas.microsoft.com/office/mac/drawingml/2011/main" xmlns="" val="0"/>
+              <ma14:wrappingTextBoxFlag xmlns="" xmlns:ma14="http://schemas.microsoft.com/office/mac/drawingml/2011/main" val="0"/>
             </a:ext>
           </a:extLst>
         </p:spPr>
@@ -6991,7 +7015,7 @@
           </a:prstGeom>
           <a:extLst>
             <a:ext uri="{C572A759-6A51-4108-AA02-DFA0A04FC94B}">
-              <ma14:wrappingTextBoxFlag xmlns:ma14="http://schemas.microsoft.com/office/mac/drawingml/2011/main" xmlns="" val="0"/>
+              <ma14:wrappingTextBoxFlag xmlns="" xmlns:ma14="http://schemas.microsoft.com/office/mac/drawingml/2011/main" val="0"/>
             </a:ext>
           </a:extLst>
         </p:spPr>
@@ -7422,7 +7446,7 @@
           </a:prstGeom>
           <a:extLst>
             <a:ext uri="{C572A759-6A51-4108-AA02-DFA0A04FC94B}">
-              <ma14:wrappingTextBoxFlag xmlns:ma14="http://schemas.microsoft.com/office/mac/drawingml/2011/main" xmlns="" val="0"/>
+              <ma14:wrappingTextBoxFlag xmlns="" xmlns:ma14="http://schemas.microsoft.com/office/mac/drawingml/2011/main" val="0"/>
             </a:ext>
           </a:extLst>
         </p:spPr>
@@ -8771,7 +8795,7 @@
           </a:prstGeom>
           <a:extLst>
             <a:ext uri="{C572A759-6A51-4108-AA02-DFA0A04FC94B}">
-              <ma14:wrappingTextBoxFlag xmlns:ma14="http://schemas.microsoft.com/office/mac/drawingml/2011/main" xmlns="" val="0"/>
+              <ma14:wrappingTextBoxFlag xmlns="" xmlns:ma14="http://schemas.microsoft.com/office/mac/drawingml/2011/main" val="0"/>
             </a:ext>
           </a:extLst>
         </p:spPr>
@@ -9037,7 +9061,7 @@
           </a:prstGeom>
           <a:extLst>
             <a:ext uri="{C572A759-6A51-4108-AA02-DFA0A04FC94B}">
-              <ma14:wrappingTextBoxFlag xmlns:ma14="http://schemas.microsoft.com/office/mac/drawingml/2011/main" xmlns="" val="0"/>
+              <ma14:wrappingTextBoxFlag xmlns="" xmlns:ma14="http://schemas.microsoft.com/office/mac/drawingml/2011/main" val="0"/>
             </a:ext>
           </a:extLst>
         </p:spPr>
@@ -10098,7 +10122,7 @@
           </a:prstGeom>
           <a:extLst>
             <a:ext uri="{C572A759-6A51-4108-AA02-DFA0A04FC94B}">
-              <ma14:wrappingTextBoxFlag xmlns:ma14="http://schemas.microsoft.com/office/mac/drawingml/2011/main" xmlns="" val="0"/>
+              <ma14:wrappingTextBoxFlag xmlns="" xmlns:ma14="http://schemas.microsoft.com/office/mac/drawingml/2011/main" val="0"/>
             </a:ext>
           </a:extLst>
         </p:spPr>
@@ -10624,7 +10648,7 @@
           </a:prstGeom>
           <a:extLst>
             <a:ext uri="{C572A759-6A51-4108-AA02-DFA0A04FC94B}">
-              <ma14:wrappingTextBoxFlag xmlns:ma14="http://schemas.microsoft.com/office/mac/drawingml/2011/main" xmlns="" val="0"/>
+              <ma14:wrappingTextBoxFlag xmlns="" xmlns:ma14="http://schemas.microsoft.com/office/mac/drawingml/2011/main" val="0"/>
             </a:ext>
           </a:extLst>
         </p:spPr>

</xml_diff>